<commit_message>
Banner: conclusão sobre o status do embrião, metodologia, Enunciado 267 e páginas das citações
Co-Authored-By: Claude Opus 5.5 <noreply@anthropic.com>
Claude-Session: https://claude.ai/code/session_0176U9jodFC8XWfeFASD67mk
</commit_message>
<xml_diff>
--- a/Banner_TCC_Ana_Livia_final.pptx
+++ b/Banner_TCC_Ana_Livia_final.pptx
@@ -1090,7 +1090,7 @@
           <a:p>
             <a:pPr algn="just">
               <a:lnSpc>
-                <a:spcPct val="150000"/>
+                <a:spcPct val="130000"/>
               </a:lnSpc>
               <a:tabLst>
                 <a:tab algn="l" pos="0"/>
@@ -1180,19 +1180,19 @@
                 <a:latin typeface="Times New Roman"/>
                 <a:ea typeface="Times New Roman"/>
               </a:rPr>
-              <a:t> jurídico do embrião criopreservado e o direito à herança dessa criança, à luz da doutrina, da legislação e da jurisprudência do Superior Tribunal de Justiça.</a:t>
-            </a:r>
-            <a:endParaRPr b="0" lang="en-US" sz="3500" spc="-1" strike="noStrike">
-              <a:solidFill>
-                <a:srgbClr val="000000"/>
-              </a:solidFill>
-              <a:latin typeface="Arial"/>
-            </a:endParaRPr>
-          </a:p>
-          <a:p>
-            <a:pPr algn="just">
-              <a:lnSpc>
-                <a:spcPct val="150000"/>
+              <a:t> jurídico do embrião criopreservado e o direito à herança dessa criança, à luz da doutrina, da legislação e da jurisprudência do Superior Tribunal de Justiça. Para tanto, realizou-se pesquisa bibliográfica sobre a legislação, a doutrina, a jurisprudência e o anteprojeto de revisão do Código Civil (2026) pertinentes ao tema.</a:t>
+            </a:r>
+            <a:endParaRPr b="0" lang="en-US" sz="3500" spc="-1" strike="noStrike">
+              <a:solidFill>
+                <a:srgbClr val="000000"/>
+              </a:solidFill>
+              <a:latin typeface="Arial"/>
+            </a:endParaRPr>
+          </a:p>
+          <a:p>
+            <a:pPr algn="just">
+              <a:lnSpc>
+                <a:spcPct val="130000"/>
               </a:lnSpc>
               <a:tabLst>
                 <a:tab algn="l" pos="0"/>
@@ -1214,7 +1214,7 @@
           <a:p>
             <a:pPr algn="just">
               <a:lnSpc>
-                <a:spcPct val="150000"/>
+                <a:spcPct val="130000"/>
               </a:lnSpc>
               <a:tabLst>
                 <a:tab algn="l" pos="0"/>
@@ -1236,7 +1236,7 @@
           <a:p>
             <a:pPr algn="just">
               <a:lnSpc>
-                <a:spcPct val="150000"/>
+                <a:spcPct val="130000"/>
               </a:lnSpc>
               <a:tabLst>
                 <a:tab algn="l" pos="0"/>
@@ -1258,7 +1258,7 @@
           <a:p>
             <a:pPr algn="just">
               <a:lnSpc>
-                <a:spcPct val="150000"/>
+                <a:spcPct val="130000"/>
               </a:lnSpc>
               <a:tabLst>
                 <a:tab algn="l" pos="0"/>
@@ -1287,7 +1287,7 @@
         </p:nvSpPr>
         <p:spPr>
           <a:xfrm>
-            <a:off x="1182600" y="18472320"/>
+            <a:off x="1182600" y="19440000"/>
             <a:ext cx="16198920" cy="627480"/>
           </a:xfrm>
           <a:prstGeom prst="rect">
@@ -1347,7 +1347,7 @@
         </p:nvSpPr>
         <p:spPr>
           <a:xfrm>
-            <a:off x="1166760" y="18411840"/>
+            <a:off x="1166760" y="19368000"/>
             <a:ext cx="15105240" cy="26236440"/>
           </a:xfrm>
           <a:prstGeom prst="rect">
@@ -1371,7 +1371,7 @@
           <a:p>
             <a:pPr algn="just">
               <a:lnSpc>
-                <a:spcPct val="150000"/>
+                <a:spcPct val="130000"/>
               </a:lnSpc>
               <a:tabLst>
                 <a:tab algn="l" pos="0"/>
@@ -1390,7 +1390,7 @@
           <a:p>
             <a:pPr algn="just" indent="900000">
               <a:lnSpc>
-                <a:spcPct val="150000"/>
+                <a:spcPct val="130000"/>
               </a:lnSpc>
               <a:tabLst>
                 <a:tab algn="l" pos="0"/>
@@ -1407,17 +1407,17 @@
                 <a:latin typeface="Times New Roman"/>
                 <a:ea typeface="Calibri"/>
               </a:rPr>
-              <a:t>A controvérsia sobre a natureza jurídica do embrião criopreservado opõe três correntes: a natalista, majoritária no Brasil, para a qual a personalidade jurídica só se adquire com o nascimento com vida; a concepcionista, que a reconhece desde a concepção, ainda que extrauterina; e a da personalidade condicional, intermediária entre as duas (MARTINS; WINCK; MIRANDA, 2026). O Código Civil (2026) não disciplina a forma exigida para o consentimento do genitor falecido quanto ao uso póstumo de seu material genético, lacuna parcialmente suprida pela Resolução CFM nº 2.320/2022 (2026), de caráter apenas ético-profissional e sem força de lei. O princípio da Saisine e a capacidade sucessória passiva (arts. 1.784 e 1.798 do Código Civil) pressupõem herdeiro já concebido na abertura da sucessão — pressuposto que a criança concebida </a:t>
-            </a:r>
-            <a:r>
-              <a:rPr b="0" i="1" lang="pt-BR" sz="3500" spc="-1" strike="noStrike">
+              <a:t>A controvérsia sobre a natureza jurídica do embrião criopreservado opõe três correntes: a natalista, majoritária no Brasil, para a qual a personalidade jurídica só se adquire com o nascimento com vida; a concepcionista, que a reconhece desde a concepção, ainda que extrauterina; e a da personalidade condicional, intermediária entre as duas (MARTINS; WINCK; MIRANDA, 2026, p. 318). O Código Civil (2026) não disciplina a forma exigida para o consentimento do genitor falecido quanto ao uso póstumo de seu material genético, lacuna parcialmente suprida pela Resolução CFM nº 2.320/2022 (2026), de caráter apenas ético-profissional e sem força de lei. O Enunciado nº 267 do CJF (2004) estendeu a regra do art. 1.798 do Código Civil, que exige herdeiro já concebido na abertura da sucessão, aos embriões formados por reprodução assistida, submetendo seus efeitos patrimoniais às regras da petição de herança.</a:t>
+            </a:r>
+            <a:r>
+              <a:rPr b="0" lang="pt-BR" sz="3500" spc="-1" strike="noStrike">
                 <a:solidFill>
                   <a:srgbClr val="000000"/>
                 </a:solidFill>
                 <a:latin typeface="Times New Roman"/>
                 <a:ea typeface="Calibri"/>
               </a:rPr>
-              <a:t>post mortem </a:t>
+              <a:t> Persiste, assim, a tensão entre a igualdade absoluta entre os filhos (art. 227, §6º, CF) e a segurança jurídica dos coerdeiros já existentes (GONÇALVES, 2026, p. 38). No REsp 1.918.421/SP, o Superior Tribunal de Justiça (2021) fixou que a autorização para uso póstumo de embriões exige forma expressa e incontestável, “alcançada por meio do testamento ou instrumento que o valha em formalidade e garantia”, afastando a validade de contratos padrão firmados com clínicas de reprodução assistida. </a:t>
             </a:r>
             <a:r>
               <a:rPr b="0" lang="pt-BR" sz="3500" spc="-1" strike="noStrike">
@@ -1427,36 +1427,6 @@
                 <a:latin typeface="Times New Roman"/>
                 <a:ea typeface="Calibri"/>
               </a:rPr>
-              <a:t>não satisfaz </a:t>
-            </a:r>
-            <a:r>
-              <a:rPr b="0" lang="pt-BR" sz="3500" spc="-1" strike="noStrike">
-                <a:solidFill>
-                  <a:srgbClr val="000000"/>
-                </a:solidFill>
-                <a:latin typeface="Times New Roman"/>
-                <a:ea typeface="Times New Roman"/>
-              </a:rPr>
-              <a:t>(GONÇALVES, 2026, p. 13)</a:t>
-            </a:r>
-            <a:r>
-              <a:rPr b="0" lang="pt-BR" sz="3500" spc="-1" strike="noStrike">
-                <a:solidFill>
-                  <a:srgbClr val="000000"/>
-                </a:solidFill>
-                <a:latin typeface="Times New Roman"/>
-                <a:ea typeface="Calibri"/>
-              </a:rPr>
-              <a:t>. Persiste, assim, a tensão entre a igualdade absoluta entre os filhos (art. 227, §6º, CF) e a segurança jurídica dos coerdeiros já existentes (GONÇALVES, 2026). No REsp 1.918.421/SP, o Superior Tribunal de Justiça (2021) fixou que a autorização para uso póstumo de embriões exige forma expressa e incontestável, “alcançada por meio do testamento ou instrumento que o valha em formalidade e garantia”, afastando a validade de contratos padrão firmados com clínicas de reprodução assistida. </a:t>
-            </a:r>
-            <a:r>
-              <a:rPr b="0" lang="pt-BR" sz="3500" spc="-1" strike="noStrike">
-                <a:solidFill>
-                  <a:srgbClr val="000000"/>
-                </a:solidFill>
-                <a:latin typeface="Times New Roman"/>
-                <a:ea typeface="Calibri"/>
-              </a:rPr>
               <a:t>O Anteprojeto de Reforma do Código Civil (2026) tende a consolidar esse entendimento, exigindo escritura pública ou testamento público para a autorização do uso póstumo do material genético e fixando prazo de dois anos, contado da abertura da sucessão, para os efeitos sucessórios patrimoniais</a:t>
             </a:r>
             <a:endParaRPr b="0" lang="en-US" sz="3500" spc="-1" strike="noStrike">
@@ -1469,197 +1439,197 @@
           <a:p>
             <a:pPr algn="just">
               <a:lnSpc>
-                <a:spcPct val="150000"/>
-              </a:lnSpc>
-              <a:tabLst>
-                <a:tab algn="l" pos="0"/>
-                <a:tab algn="l" pos="3535200"/>
-                <a:tab algn="l" pos="7070760"/>
-                <a:tab algn="l" pos="10605960"/>
-              </a:tabLst>
-            </a:pPr>
-            <a:endParaRPr b="0" lang="en-US" sz="3500" spc="-1" strike="noStrike">
-              <a:solidFill>
-                <a:srgbClr val="000000"/>
-              </a:solidFill>
-              <a:latin typeface="Arial"/>
-            </a:endParaRPr>
-          </a:p>
-          <a:p>
-            <a:pPr algn="just">
-              <a:lnSpc>
-                <a:spcPct val="150000"/>
-              </a:lnSpc>
-              <a:tabLst>
-                <a:tab algn="l" pos="0"/>
-                <a:tab algn="l" pos="3535200"/>
-                <a:tab algn="l" pos="7070760"/>
-                <a:tab algn="l" pos="10605960"/>
-              </a:tabLst>
-            </a:pPr>
-            <a:endParaRPr b="0" lang="en-US" sz="3500" spc="-1" strike="noStrike">
-              <a:solidFill>
-                <a:srgbClr val="000000"/>
-              </a:solidFill>
-              <a:latin typeface="Arial"/>
-            </a:endParaRPr>
-          </a:p>
-          <a:p>
-            <a:pPr algn="just">
-              <a:lnSpc>
-                <a:spcPct val="150000"/>
-              </a:lnSpc>
-              <a:tabLst>
-                <a:tab algn="l" pos="0"/>
-                <a:tab algn="l" pos="3535200"/>
-                <a:tab algn="l" pos="7070760"/>
-                <a:tab algn="l" pos="10605960"/>
-              </a:tabLst>
-            </a:pPr>
-            <a:endParaRPr b="0" lang="en-US" sz="3500" spc="-1" strike="noStrike">
-              <a:solidFill>
-                <a:srgbClr val="000000"/>
-              </a:solidFill>
-              <a:latin typeface="Arial"/>
-            </a:endParaRPr>
-          </a:p>
-          <a:p>
-            <a:pPr algn="just">
-              <a:lnSpc>
-                <a:spcPct val="150000"/>
-              </a:lnSpc>
-              <a:tabLst>
-                <a:tab algn="l" pos="0"/>
-                <a:tab algn="l" pos="3535200"/>
-                <a:tab algn="l" pos="7070760"/>
-                <a:tab algn="l" pos="10605960"/>
-              </a:tabLst>
-            </a:pPr>
-            <a:endParaRPr b="0" lang="en-US" sz="3500" spc="-1" strike="noStrike">
-              <a:solidFill>
-                <a:srgbClr val="000000"/>
-              </a:solidFill>
-              <a:latin typeface="Arial"/>
-            </a:endParaRPr>
-          </a:p>
-          <a:p>
-            <a:pPr algn="just">
-              <a:lnSpc>
-                <a:spcPct val="150000"/>
-              </a:lnSpc>
-              <a:tabLst>
-                <a:tab algn="l" pos="0"/>
-                <a:tab algn="l" pos="3535200"/>
-                <a:tab algn="l" pos="7070760"/>
-                <a:tab algn="l" pos="10605960"/>
-              </a:tabLst>
-            </a:pPr>
-            <a:endParaRPr b="0" lang="en-US" sz="3500" spc="-1" strike="noStrike">
-              <a:solidFill>
-                <a:srgbClr val="000000"/>
-              </a:solidFill>
-              <a:latin typeface="Arial"/>
-            </a:endParaRPr>
-          </a:p>
-          <a:p>
-            <a:pPr algn="just">
-              <a:lnSpc>
-                <a:spcPct val="150000"/>
-              </a:lnSpc>
-              <a:tabLst>
-                <a:tab algn="l" pos="0"/>
-                <a:tab algn="l" pos="3535200"/>
-                <a:tab algn="l" pos="7070760"/>
-                <a:tab algn="l" pos="10605960"/>
-              </a:tabLst>
-            </a:pPr>
-            <a:endParaRPr b="0" lang="en-US" sz="3500" spc="-1" strike="noStrike">
-              <a:solidFill>
-                <a:srgbClr val="000000"/>
-              </a:solidFill>
-              <a:latin typeface="Arial"/>
-            </a:endParaRPr>
-          </a:p>
-          <a:p>
-            <a:pPr algn="just">
-              <a:lnSpc>
-                <a:spcPct val="150000"/>
-              </a:lnSpc>
-              <a:tabLst>
-                <a:tab algn="l" pos="0"/>
-                <a:tab algn="l" pos="3535200"/>
-                <a:tab algn="l" pos="7070760"/>
-                <a:tab algn="l" pos="10605960"/>
-              </a:tabLst>
-            </a:pPr>
-            <a:endParaRPr b="0" lang="en-US" sz="3500" spc="-1" strike="noStrike">
-              <a:solidFill>
-                <a:srgbClr val="000000"/>
-              </a:solidFill>
-              <a:latin typeface="Arial"/>
-            </a:endParaRPr>
-          </a:p>
-          <a:p>
-            <a:pPr algn="just">
-              <a:lnSpc>
-                <a:spcPct val="150000"/>
-              </a:lnSpc>
-              <a:tabLst>
-                <a:tab algn="l" pos="0"/>
-                <a:tab algn="l" pos="3535200"/>
-                <a:tab algn="l" pos="7070760"/>
-                <a:tab algn="l" pos="10605960"/>
-              </a:tabLst>
-            </a:pPr>
-            <a:endParaRPr b="0" lang="en-US" sz="3500" spc="-1" strike="noStrike">
-              <a:solidFill>
-                <a:srgbClr val="000000"/>
-              </a:solidFill>
-              <a:latin typeface="Arial"/>
-            </a:endParaRPr>
-          </a:p>
-          <a:p>
-            <a:pPr algn="just">
-              <a:lnSpc>
-                <a:spcPct val="150000"/>
-              </a:lnSpc>
-              <a:tabLst>
-                <a:tab algn="l" pos="0"/>
-                <a:tab algn="l" pos="3535200"/>
-                <a:tab algn="l" pos="7070760"/>
-                <a:tab algn="l" pos="10605960"/>
-              </a:tabLst>
-            </a:pPr>
-            <a:endParaRPr b="0" lang="en-US" sz="3500" spc="-1" strike="noStrike">
-              <a:solidFill>
-                <a:srgbClr val="000000"/>
-              </a:solidFill>
-              <a:latin typeface="Arial"/>
-            </a:endParaRPr>
-          </a:p>
-          <a:p>
-            <a:pPr algn="just">
-              <a:lnSpc>
-                <a:spcPct val="150000"/>
-              </a:lnSpc>
-              <a:tabLst>
-                <a:tab algn="l" pos="0"/>
-                <a:tab algn="l" pos="3535200"/>
-                <a:tab algn="l" pos="7070760"/>
-                <a:tab algn="l" pos="10605960"/>
-              </a:tabLst>
-            </a:pPr>
-            <a:endParaRPr b="0" lang="en-US" sz="3500" spc="-1" strike="noStrike">
-              <a:solidFill>
-                <a:srgbClr val="000000"/>
-              </a:solidFill>
-              <a:latin typeface="Arial"/>
-            </a:endParaRPr>
-          </a:p>
-          <a:p>
-            <a:pPr algn="just">
-              <a:lnSpc>
-                <a:spcPct val="150000"/>
+                <a:spcPct val="130000"/>
+              </a:lnSpc>
+              <a:tabLst>
+                <a:tab algn="l" pos="0"/>
+                <a:tab algn="l" pos="3535200"/>
+                <a:tab algn="l" pos="7070760"/>
+                <a:tab algn="l" pos="10605960"/>
+              </a:tabLst>
+            </a:pPr>
+            <a:endParaRPr b="0" lang="en-US" sz="3500" spc="-1" strike="noStrike">
+              <a:solidFill>
+                <a:srgbClr val="000000"/>
+              </a:solidFill>
+              <a:latin typeface="Arial"/>
+            </a:endParaRPr>
+          </a:p>
+          <a:p>
+            <a:pPr algn="just">
+              <a:lnSpc>
+                <a:spcPct val="130000"/>
+              </a:lnSpc>
+              <a:tabLst>
+                <a:tab algn="l" pos="0"/>
+                <a:tab algn="l" pos="3535200"/>
+                <a:tab algn="l" pos="7070760"/>
+                <a:tab algn="l" pos="10605960"/>
+              </a:tabLst>
+            </a:pPr>
+            <a:endParaRPr b="0" lang="en-US" sz="3500" spc="-1" strike="noStrike">
+              <a:solidFill>
+                <a:srgbClr val="000000"/>
+              </a:solidFill>
+              <a:latin typeface="Arial"/>
+            </a:endParaRPr>
+          </a:p>
+          <a:p>
+            <a:pPr algn="just">
+              <a:lnSpc>
+                <a:spcPct val="130000"/>
+              </a:lnSpc>
+              <a:tabLst>
+                <a:tab algn="l" pos="0"/>
+                <a:tab algn="l" pos="3535200"/>
+                <a:tab algn="l" pos="7070760"/>
+                <a:tab algn="l" pos="10605960"/>
+              </a:tabLst>
+            </a:pPr>
+            <a:endParaRPr b="0" lang="en-US" sz="3500" spc="-1" strike="noStrike">
+              <a:solidFill>
+                <a:srgbClr val="000000"/>
+              </a:solidFill>
+              <a:latin typeface="Arial"/>
+            </a:endParaRPr>
+          </a:p>
+          <a:p>
+            <a:pPr algn="just">
+              <a:lnSpc>
+                <a:spcPct val="130000"/>
+              </a:lnSpc>
+              <a:tabLst>
+                <a:tab algn="l" pos="0"/>
+                <a:tab algn="l" pos="3535200"/>
+                <a:tab algn="l" pos="7070760"/>
+                <a:tab algn="l" pos="10605960"/>
+              </a:tabLst>
+            </a:pPr>
+            <a:endParaRPr b="0" lang="en-US" sz="3500" spc="-1" strike="noStrike">
+              <a:solidFill>
+                <a:srgbClr val="000000"/>
+              </a:solidFill>
+              <a:latin typeface="Arial"/>
+            </a:endParaRPr>
+          </a:p>
+          <a:p>
+            <a:pPr algn="just">
+              <a:lnSpc>
+                <a:spcPct val="130000"/>
+              </a:lnSpc>
+              <a:tabLst>
+                <a:tab algn="l" pos="0"/>
+                <a:tab algn="l" pos="3535200"/>
+                <a:tab algn="l" pos="7070760"/>
+                <a:tab algn="l" pos="10605960"/>
+              </a:tabLst>
+            </a:pPr>
+            <a:endParaRPr b="0" lang="en-US" sz="3500" spc="-1" strike="noStrike">
+              <a:solidFill>
+                <a:srgbClr val="000000"/>
+              </a:solidFill>
+              <a:latin typeface="Arial"/>
+            </a:endParaRPr>
+          </a:p>
+          <a:p>
+            <a:pPr algn="just">
+              <a:lnSpc>
+                <a:spcPct val="130000"/>
+              </a:lnSpc>
+              <a:tabLst>
+                <a:tab algn="l" pos="0"/>
+                <a:tab algn="l" pos="3535200"/>
+                <a:tab algn="l" pos="7070760"/>
+                <a:tab algn="l" pos="10605960"/>
+              </a:tabLst>
+            </a:pPr>
+            <a:endParaRPr b="0" lang="en-US" sz="3500" spc="-1" strike="noStrike">
+              <a:solidFill>
+                <a:srgbClr val="000000"/>
+              </a:solidFill>
+              <a:latin typeface="Arial"/>
+            </a:endParaRPr>
+          </a:p>
+          <a:p>
+            <a:pPr algn="just">
+              <a:lnSpc>
+                <a:spcPct val="130000"/>
+              </a:lnSpc>
+              <a:tabLst>
+                <a:tab algn="l" pos="0"/>
+                <a:tab algn="l" pos="3535200"/>
+                <a:tab algn="l" pos="7070760"/>
+                <a:tab algn="l" pos="10605960"/>
+              </a:tabLst>
+            </a:pPr>
+            <a:endParaRPr b="0" lang="en-US" sz="3500" spc="-1" strike="noStrike">
+              <a:solidFill>
+                <a:srgbClr val="000000"/>
+              </a:solidFill>
+              <a:latin typeface="Arial"/>
+            </a:endParaRPr>
+          </a:p>
+          <a:p>
+            <a:pPr algn="just">
+              <a:lnSpc>
+                <a:spcPct val="130000"/>
+              </a:lnSpc>
+              <a:tabLst>
+                <a:tab algn="l" pos="0"/>
+                <a:tab algn="l" pos="3535200"/>
+                <a:tab algn="l" pos="7070760"/>
+                <a:tab algn="l" pos="10605960"/>
+              </a:tabLst>
+            </a:pPr>
+            <a:endParaRPr b="0" lang="en-US" sz="3500" spc="-1" strike="noStrike">
+              <a:solidFill>
+                <a:srgbClr val="000000"/>
+              </a:solidFill>
+              <a:latin typeface="Arial"/>
+            </a:endParaRPr>
+          </a:p>
+          <a:p>
+            <a:pPr algn="just">
+              <a:lnSpc>
+                <a:spcPct val="130000"/>
+              </a:lnSpc>
+              <a:tabLst>
+                <a:tab algn="l" pos="0"/>
+                <a:tab algn="l" pos="3535200"/>
+                <a:tab algn="l" pos="7070760"/>
+                <a:tab algn="l" pos="10605960"/>
+              </a:tabLst>
+            </a:pPr>
+            <a:endParaRPr b="0" lang="en-US" sz="3500" spc="-1" strike="noStrike">
+              <a:solidFill>
+                <a:srgbClr val="000000"/>
+              </a:solidFill>
+              <a:latin typeface="Arial"/>
+            </a:endParaRPr>
+          </a:p>
+          <a:p>
+            <a:pPr algn="just">
+              <a:lnSpc>
+                <a:spcPct val="130000"/>
+              </a:lnSpc>
+              <a:tabLst>
+                <a:tab algn="l" pos="0"/>
+                <a:tab algn="l" pos="3535200"/>
+                <a:tab algn="l" pos="7070760"/>
+                <a:tab algn="l" pos="10605960"/>
+              </a:tabLst>
+            </a:pPr>
+            <a:endParaRPr b="0" lang="en-US" sz="3500" spc="-1" strike="noStrike">
+              <a:solidFill>
+                <a:srgbClr val="000000"/>
+              </a:solidFill>
+              <a:latin typeface="Arial"/>
+            </a:endParaRPr>
+          </a:p>
+          <a:p>
+            <a:pPr algn="just">
+              <a:lnSpc>
+                <a:spcPct val="130000"/>
               </a:lnSpc>
               <a:tabLst>
                 <a:tab algn="l" pos="0"/>
@@ -1709,7 +1679,7 @@
           <a:p>
             <a:pPr algn="just">
               <a:lnSpc>
-                <a:spcPct val="150000"/>
+                <a:spcPct val="130000"/>
               </a:lnSpc>
               <a:tabLst>
                 <a:tab algn="l" pos="0"/>
@@ -1757,374 +1727,446 @@
           </a:p>
           <a:p>
             <a:pPr algn="just">
-              <a:tabLst>
-                <a:tab algn="l" pos="0"/>
-                <a:tab algn="l" pos="3535200"/>
-                <a:tab algn="l" pos="7070760"/>
-                <a:tab algn="l" pos="10605960"/>
-              </a:tabLst>
-            </a:pPr>
-            <a:endParaRPr b="0" lang="en-US" sz="3500" spc="-1" strike="noStrike">
-              <a:solidFill>
-                <a:srgbClr val="000000"/>
-              </a:solidFill>
-              <a:latin typeface="Arial"/>
-            </a:endParaRPr>
-          </a:p>
-          <a:p>
-            <a:pPr algn="just">
-              <a:tabLst>
-                <a:tab algn="l" pos="0"/>
-                <a:tab algn="l" pos="3535200"/>
-                <a:tab algn="l" pos="7070760"/>
-                <a:tab algn="l" pos="10605960"/>
-              </a:tabLst>
-            </a:pPr>
-            <a:endParaRPr b="0" lang="en-US" sz="3500" spc="-1" strike="noStrike">
-              <a:solidFill>
-                <a:srgbClr val="000000"/>
-              </a:solidFill>
-              <a:latin typeface="Arial"/>
-            </a:endParaRPr>
-          </a:p>
-          <a:p>
-            <a:pPr algn="just">
-              <a:tabLst>
-                <a:tab algn="l" pos="0"/>
-                <a:tab algn="l" pos="3535200"/>
-                <a:tab algn="l" pos="7070760"/>
-                <a:tab algn="l" pos="10605960"/>
-              </a:tabLst>
-            </a:pPr>
-            <a:endParaRPr b="0" lang="en-US" sz="3500" spc="-1" strike="noStrike">
-              <a:solidFill>
-                <a:srgbClr val="000000"/>
-              </a:solidFill>
-              <a:latin typeface="Arial"/>
-            </a:endParaRPr>
-          </a:p>
-          <a:p>
-            <a:pPr algn="just">
-              <a:tabLst>
-                <a:tab algn="l" pos="0"/>
-                <a:tab algn="l" pos="3535200"/>
-                <a:tab algn="l" pos="7070760"/>
-                <a:tab algn="l" pos="10605960"/>
-              </a:tabLst>
-            </a:pPr>
-            <a:endParaRPr b="0" lang="en-US" sz="3500" spc="-1" strike="noStrike">
-              <a:solidFill>
-                <a:srgbClr val="000000"/>
-              </a:solidFill>
-              <a:latin typeface="Arial"/>
-            </a:endParaRPr>
-          </a:p>
-          <a:p>
-            <a:pPr algn="just">
-              <a:tabLst>
-                <a:tab algn="l" pos="0"/>
-                <a:tab algn="l" pos="3535200"/>
-                <a:tab algn="l" pos="7070760"/>
-                <a:tab algn="l" pos="10605960"/>
-              </a:tabLst>
-            </a:pPr>
-            <a:endParaRPr b="0" lang="en-US" sz="3500" spc="-1" strike="noStrike">
-              <a:solidFill>
-                <a:srgbClr val="000000"/>
-              </a:solidFill>
-              <a:latin typeface="Arial"/>
-            </a:endParaRPr>
-          </a:p>
-          <a:p>
-            <a:pPr algn="just">
-              <a:tabLst>
-                <a:tab algn="l" pos="0"/>
-                <a:tab algn="l" pos="3535200"/>
-                <a:tab algn="l" pos="7070760"/>
-                <a:tab algn="l" pos="10605960"/>
-              </a:tabLst>
-            </a:pPr>
-            <a:endParaRPr b="0" lang="en-US" sz="3500" spc="-1" strike="noStrike">
-              <a:solidFill>
-                <a:srgbClr val="000000"/>
-              </a:solidFill>
-              <a:latin typeface="Arial"/>
-            </a:endParaRPr>
-          </a:p>
-          <a:p>
-            <a:pPr algn="just">
-              <a:tabLst>
-                <a:tab algn="l" pos="0"/>
-                <a:tab algn="l" pos="3535200"/>
-                <a:tab algn="l" pos="7070760"/>
-                <a:tab algn="l" pos="10605960"/>
-              </a:tabLst>
-            </a:pPr>
-            <a:endParaRPr b="0" lang="en-US" sz="3500" spc="-1" strike="noStrike">
-              <a:solidFill>
-                <a:srgbClr val="000000"/>
-              </a:solidFill>
-              <a:latin typeface="Arial"/>
-            </a:endParaRPr>
-          </a:p>
-          <a:p>
-            <a:pPr algn="just">
-              <a:tabLst>
-                <a:tab algn="l" pos="0"/>
-                <a:tab algn="l" pos="3535200"/>
-                <a:tab algn="l" pos="7070760"/>
-                <a:tab algn="l" pos="10605960"/>
-              </a:tabLst>
-            </a:pPr>
-            <a:endParaRPr b="0" lang="en-US" sz="3500" spc="-1" strike="noStrike">
-              <a:solidFill>
-                <a:srgbClr val="000000"/>
-              </a:solidFill>
-              <a:latin typeface="Arial"/>
-            </a:endParaRPr>
-          </a:p>
-          <a:p>
-            <a:pPr algn="just">
-              <a:tabLst>
-                <a:tab algn="l" pos="0"/>
-                <a:tab algn="l" pos="3535200"/>
-                <a:tab algn="l" pos="7070760"/>
-                <a:tab algn="l" pos="10605960"/>
-              </a:tabLst>
-            </a:pPr>
-            <a:endParaRPr b="0" lang="en-US" sz="3500" spc="-1" strike="noStrike">
-              <a:solidFill>
-                <a:srgbClr val="000000"/>
-              </a:solidFill>
-              <a:latin typeface="Arial"/>
-            </a:endParaRPr>
-          </a:p>
-          <a:p>
-            <a:pPr algn="just">
-              <a:tabLst>
-                <a:tab algn="l" pos="0"/>
-                <a:tab algn="l" pos="3535200"/>
-                <a:tab algn="l" pos="7070760"/>
-                <a:tab algn="l" pos="10605960"/>
-              </a:tabLst>
-            </a:pPr>
-            <a:endParaRPr b="0" lang="en-US" sz="3500" spc="-1" strike="noStrike">
-              <a:solidFill>
-                <a:srgbClr val="000000"/>
-              </a:solidFill>
-              <a:latin typeface="Arial"/>
-            </a:endParaRPr>
-          </a:p>
-          <a:p>
-            <a:pPr algn="just">
-              <a:tabLst>
-                <a:tab algn="l" pos="0"/>
-                <a:tab algn="l" pos="3535200"/>
-                <a:tab algn="l" pos="7070760"/>
-                <a:tab algn="l" pos="10605960"/>
-              </a:tabLst>
-            </a:pPr>
-            <a:endParaRPr b="0" lang="en-US" sz="3500" spc="-1" strike="noStrike">
-              <a:solidFill>
-                <a:srgbClr val="000000"/>
-              </a:solidFill>
-              <a:latin typeface="Arial"/>
-            </a:endParaRPr>
-          </a:p>
-          <a:p>
-            <a:pPr algn="just">
-              <a:tabLst>
-                <a:tab algn="l" pos="0"/>
-                <a:tab algn="l" pos="3535200"/>
-                <a:tab algn="l" pos="7070760"/>
-                <a:tab algn="l" pos="10605960"/>
-              </a:tabLst>
-            </a:pPr>
-            <a:endParaRPr b="0" lang="en-US" sz="3500" spc="-1" strike="noStrike">
-              <a:solidFill>
-                <a:srgbClr val="000000"/>
-              </a:solidFill>
-              <a:latin typeface="Arial"/>
-            </a:endParaRPr>
-          </a:p>
-          <a:p>
-            <a:pPr algn="just">
-              <a:tabLst>
-                <a:tab algn="l" pos="0"/>
-                <a:tab algn="l" pos="3535200"/>
-                <a:tab algn="l" pos="7070760"/>
-                <a:tab algn="l" pos="10605960"/>
-              </a:tabLst>
-            </a:pPr>
-            <a:endParaRPr b="0" lang="en-US" sz="3500" spc="-1" strike="noStrike">
-              <a:solidFill>
-                <a:srgbClr val="000000"/>
-              </a:solidFill>
-              <a:latin typeface="Arial"/>
-            </a:endParaRPr>
-          </a:p>
-          <a:p>
-            <a:pPr algn="just">
-              <a:tabLst>
-                <a:tab algn="l" pos="0"/>
-                <a:tab algn="l" pos="3535200"/>
-                <a:tab algn="l" pos="7070760"/>
-                <a:tab algn="l" pos="10605960"/>
-              </a:tabLst>
-            </a:pPr>
-            <a:endParaRPr b="0" lang="en-US" sz="3500" spc="-1" strike="noStrike">
-              <a:solidFill>
-                <a:srgbClr val="000000"/>
-              </a:solidFill>
-              <a:latin typeface="Arial"/>
-            </a:endParaRPr>
-          </a:p>
-          <a:p>
-            <a:pPr algn="just">
-              <a:tabLst>
-                <a:tab algn="l" pos="0"/>
-                <a:tab algn="l" pos="3535200"/>
-                <a:tab algn="l" pos="7070760"/>
-                <a:tab algn="l" pos="10605960"/>
-              </a:tabLst>
-            </a:pPr>
-            <a:endParaRPr b="0" lang="en-US" sz="3500" spc="-1" strike="noStrike">
-              <a:solidFill>
-                <a:srgbClr val="000000"/>
-              </a:solidFill>
-              <a:latin typeface="Arial"/>
-            </a:endParaRPr>
-          </a:p>
-          <a:p>
-            <a:pPr algn="just">
-              <a:tabLst>
-                <a:tab algn="l" pos="0"/>
-                <a:tab algn="l" pos="3535200"/>
-                <a:tab algn="l" pos="7070760"/>
-                <a:tab algn="l" pos="10605960"/>
-              </a:tabLst>
-            </a:pPr>
-            <a:endParaRPr b="0" lang="en-US" sz="3500" spc="-1" strike="noStrike">
-              <a:solidFill>
-                <a:srgbClr val="000000"/>
-              </a:solidFill>
-              <a:latin typeface="Arial"/>
-            </a:endParaRPr>
-          </a:p>
-          <a:p>
-            <a:pPr algn="just">
-              <a:tabLst>
-                <a:tab algn="l" pos="0"/>
-                <a:tab algn="l" pos="3535200"/>
-                <a:tab algn="l" pos="7070760"/>
-                <a:tab algn="l" pos="10605960"/>
-              </a:tabLst>
-            </a:pPr>
-            <a:endParaRPr b="0" lang="en-US" sz="3500" spc="-1" strike="noStrike">
-              <a:solidFill>
-                <a:srgbClr val="000000"/>
-              </a:solidFill>
-              <a:latin typeface="Arial"/>
-            </a:endParaRPr>
-          </a:p>
-          <a:p>
-            <a:pPr algn="just">
-              <a:tabLst>
-                <a:tab algn="l" pos="0"/>
-                <a:tab algn="l" pos="3535200"/>
-                <a:tab algn="l" pos="7070760"/>
-                <a:tab algn="l" pos="10605960"/>
-              </a:tabLst>
-            </a:pPr>
-            <a:endParaRPr b="0" lang="en-US" sz="3500" spc="-1" strike="noStrike">
-              <a:solidFill>
-                <a:srgbClr val="000000"/>
-              </a:solidFill>
-              <a:latin typeface="Arial"/>
-            </a:endParaRPr>
-          </a:p>
-          <a:p>
-            <a:pPr algn="just">
-              <a:tabLst>
-                <a:tab algn="l" pos="0"/>
-                <a:tab algn="l" pos="3535200"/>
-                <a:tab algn="l" pos="7070760"/>
-                <a:tab algn="l" pos="10605960"/>
-              </a:tabLst>
-            </a:pPr>
-            <a:endParaRPr b="0" lang="en-US" sz="3500" spc="-1" strike="noStrike">
-              <a:solidFill>
-                <a:srgbClr val="000000"/>
-              </a:solidFill>
-              <a:latin typeface="Arial"/>
-            </a:endParaRPr>
-          </a:p>
-          <a:p>
-            <a:pPr algn="just">
-              <a:tabLst>
-                <a:tab algn="l" pos="0"/>
-                <a:tab algn="l" pos="3535200"/>
-                <a:tab algn="l" pos="7070760"/>
-                <a:tab algn="l" pos="10605960"/>
-              </a:tabLst>
-            </a:pPr>
-            <a:endParaRPr b="0" lang="en-US" sz="3500" spc="-1" strike="noStrike">
-              <a:solidFill>
-                <a:srgbClr val="000000"/>
-              </a:solidFill>
-              <a:latin typeface="Arial"/>
-            </a:endParaRPr>
-          </a:p>
-          <a:p>
-            <a:pPr algn="just">
-              <a:tabLst>
-                <a:tab algn="l" pos="0"/>
-                <a:tab algn="l" pos="3535200"/>
-                <a:tab algn="l" pos="7070760"/>
-                <a:tab algn="l" pos="10605960"/>
-              </a:tabLst>
-            </a:pPr>
-            <a:endParaRPr b="0" lang="en-US" sz="3500" spc="-1" strike="noStrike">
-              <a:solidFill>
-                <a:srgbClr val="000000"/>
-              </a:solidFill>
-              <a:latin typeface="Arial"/>
-            </a:endParaRPr>
-          </a:p>
-          <a:p>
-            <a:pPr algn="just">
-              <a:tabLst>
-                <a:tab algn="l" pos="0"/>
-                <a:tab algn="l" pos="3535200"/>
-                <a:tab algn="l" pos="7070760"/>
-                <a:tab algn="l" pos="10605960"/>
-              </a:tabLst>
-            </a:pPr>
-            <a:endParaRPr b="0" lang="en-US" sz="3500" spc="-1" strike="noStrike">
-              <a:solidFill>
-                <a:srgbClr val="000000"/>
-              </a:solidFill>
-              <a:latin typeface="Arial"/>
-            </a:endParaRPr>
-          </a:p>
-          <a:p>
-            <a:pPr algn="just">
-              <a:tabLst>
-                <a:tab algn="l" pos="0"/>
-                <a:tab algn="l" pos="3535200"/>
-                <a:tab algn="l" pos="7070760"/>
-                <a:tab algn="l" pos="10605960"/>
-              </a:tabLst>
-            </a:pPr>
-            <a:endParaRPr b="0" lang="en-US" sz="3500" spc="-1" strike="noStrike">
-              <a:solidFill>
-                <a:srgbClr val="000000"/>
-              </a:solidFill>
-              <a:latin typeface="Arial"/>
-            </a:endParaRPr>
-          </a:p>
-          <a:p>
-            <a:pPr algn="just">
+              <a:lnSpc>
+                <a:spcPct val="130000"/>
+              </a:lnSpc>
+              <a:tabLst>
+                <a:tab algn="l" pos="0"/>
+                <a:tab algn="l" pos="3535200"/>
+                <a:tab algn="l" pos="7070760"/>
+                <a:tab algn="l" pos="10605960"/>
+              </a:tabLst>
+            </a:pPr>
+            <a:endParaRPr b="0" lang="en-US" sz="3500" spc="-1" strike="noStrike">
+              <a:solidFill>
+                <a:srgbClr val="000000"/>
+              </a:solidFill>
+              <a:latin typeface="Arial"/>
+            </a:endParaRPr>
+          </a:p>
+          <a:p>
+            <a:pPr algn="just">
+              <a:lnSpc>
+                <a:spcPct val="130000"/>
+              </a:lnSpc>
+              <a:tabLst>
+                <a:tab algn="l" pos="0"/>
+                <a:tab algn="l" pos="3535200"/>
+                <a:tab algn="l" pos="7070760"/>
+                <a:tab algn="l" pos="10605960"/>
+              </a:tabLst>
+            </a:pPr>
+            <a:endParaRPr b="0" lang="en-US" sz="3500" spc="-1" strike="noStrike">
+              <a:solidFill>
+                <a:srgbClr val="000000"/>
+              </a:solidFill>
+              <a:latin typeface="Arial"/>
+            </a:endParaRPr>
+          </a:p>
+          <a:p>
+            <a:pPr algn="just">
+              <a:lnSpc>
+                <a:spcPct val="130000"/>
+              </a:lnSpc>
+              <a:tabLst>
+                <a:tab algn="l" pos="0"/>
+                <a:tab algn="l" pos="3535200"/>
+                <a:tab algn="l" pos="7070760"/>
+                <a:tab algn="l" pos="10605960"/>
+              </a:tabLst>
+            </a:pPr>
+            <a:endParaRPr b="0" lang="en-US" sz="3500" spc="-1" strike="noStrike">
+              <a:solidFill>
+                <a:srgbClr val="000000"/>
+              </a:solidFill>
+              <a:latin typeface="Arial"/>
+            </a:endParaRPr>
+          </a:p>
+          <a:p>
+            <a:pPr algn="just">
+              <a:lnSpc>
+                <a:spcPct val="130000"/>
+              </a:lnSpc>
+              <a:tabLst>
+                <a:tab algn="l" pos="0"/>
+                <a:tab algn="l" pos="3535200"/>
+                <a:tab algn="l" pos="7070760"/>
+                <a:tab algn="l" pos="10605960"/>
+              </a:tabLst>
+            </a:pPr>
+            <a:endParaRPr b="0" lang="en-US" sz="3500" spc="-1" strike="noStrike">
+              <a:solidFill>
+                <a:srgbClr val="000000"/>
+              </a:solidFill>
+              <a:latin typeface="Arial"/>
+            </a:endParaRPr>
+          </a:p>
+          <a:p>
+            <a:pPr algn="just">
+              <a:lnSpc>
+                <a:spcPct val="130000"/>
+              </a:lnSpc>
+              <a:tabLst>
+                <a:tab algn="l" pos="0"/>
+                <a:tab algn="l" pos="3535200"/>
+                <a:tab algn="l" pos="7070760"/>
+                <a:tab algn="l" pos="10605960"/>
+              </a:tabLst>
+            </a:pPr>
+            <a:endParaRPr b="0" lang="en-US" sz="3500" spc="-1" strike="noStrike">
+              <a:solidFill>
+                <a:srgbClr val="000000"/>
+              </a:solidFill>
+              <a:latin typeface="Arial"/>
+            </a:endParaRPr>
+          </a:p>
+          <a:p>
+            <a:pPr algn="just">
+              <a:lnSpc>
+                <a:spcPct val="130000"/>
+              </a:lnSpc>
+              <a:tabLst>
+                <a:tab algn="l" pos="0"/>
+                <a:tab algn="l" pos="3535200"/>
+                <a:tab algn="l" pos="7070760"/>
+                <a:tab algn="l" pos="10605960"/>
+              </a:tabLst>
+            </a:pPr>
+            <a:endParaRPr b="0" lang="en-US" sz="3500" spc="-1" strike="noStrike">
+              <a:solidFill>
+                <a:srgbClr val="000000"/>
+              </a:solidFill>
+              <a:latin typeface="Arial"/>
+            </a:endParaRPr>
+          </a:p>
+          <a:p>
+            <a:pPr algn="just">
+              <a:lnSpc>
+                <a:spcPct val="130000"/>
+              </a:lnSpc>
+              <a:tabLst>
+                <a:tab algn="l" pos="0"/>
+                <a:tab algn="l" pos="3535200"/>
+                <a:tab algn="l" pos="7070760"/>
+                <a:tab algn="l" pos="10605960"/>
+              </a:tabLst>
+            </a:pPr>
+            <a:endParaRPr b="0" lang="en-US" sz="3500" spc="-1" strike="noStrike">
+              <a:solidFill>
+                <a:srgbClr val="000000"/>
+              </a:solidFill>
+              <a:latin typeface="Arial"/>
+            </a:endParaRPr>
+          </a:p>
+          <a:p>
+            <a:pPr algn="just">
+              <a:lnSpc>
+                <a:spcPct val="130000"/>
+              </a:lnSpc>
+              <a:tabLst>
+                <a:tab algn="l" pos="0"/>
+                <a:tab algn="l" pos="3535200"/>
+                <a:tab algn="l" pos="7070760"/>
+                <a:tab algn="l" pos="10605960"/>
+              </a:tabLst>
+            </a:pPr>
+            <a:endParaRPr b="0" lang="en-US" sz="3500" spc="-1" strike="noStrike">
+              <a:solidFill>
+                <a:srgbClr val="000000"/>
+              </a:solidFill>
+              <a:latin typeface="Arial"/>
+            </a:endParaRPr>
+          </a:p>
+          <a:p>
+            <a:pPr algn="just">
+              <a:lnSpc>
+                <a:spcPct val="130000"/>
+              </a:lnSpc>
+              <a:tabLst>
+                <a:tab algn="l" pos="0"/>
+                <a:tab algn="l" pos="3535200"/>
+                <a:tab algn="l" pos="7070760"/>
+                <a:tab algn="l" pos="10605960"/>
+              </a:tabLst>
+            </a:pPr>
+            <a:endParaRPr b="0" lang="en-US" sz="3500" spc="-1" strike="noStrike">
+              <a:solidFill>
+                <a:srgbClr val="000000"/>
+              </a:solidFill>
+              <a:latin typeface="Arial"/>
+            </a:endParaRPr>
+          </a:p>
+          <a:p>
+            <a:pPr algn="just">
+              <a:lnSpc>
+                <a:spcPct val="130000"/>
+              </a:lnSpc>
+              <a:tabLst>
+                <a:tab algn="l" pos="0"/>
+                <a:tab algn="l" pos="3535200"/>
+                <a:tab algn="l" pos="7070760"/>
+                <a:tab algn="l" pos="10605960"/>
+              </a:tabLst>
+            </a:pPr>
+            <a:endParaRPr b="0" lang="en-US" sz="3500" spc="-1" strike="noStrike">
+              <a:solidFill>
+                <a:srgbClr val="000000"/>
+              </a:solidFill>
+              <a:latin typeface="Arial"/>
+            </a:endParaRPr>
+          </a:p>
+          <a:p>
+            <a:pPr algn="just">
+              <a:lnSpc>
+                <a:spcPct val="130000"/>
+              </a:lnSpc>
+              <a:tabLst>
+                <a:tab algn="l" pos="0"/>
+                <a:tab algn="l" pos="3535200"/>
+                <a:tab algn="l" pos="7070760"/>
+                <a:tab algn="l" pos="10605960"/>
+              </a:tabLst>
+            </a:pPr>
+            <a:endParaRPr b="0" lang="en-US" sz="3500" spc="-1" strike="noStrike">
+              <a:solidFill>
+                <a:srgbClr val="000000"/>
+              </a:solidFill>
+              <a:latin typeface="Arial"/>
+            </a:endParaRPr>
+          </a:p>
+          <a:p>
+            <a:pPr algn="just">
+              <a:lnSpc>
+                <a:spcPct val="130000"/>
+              </a:lnSpc>
+              <a:tabLst>
+                <a:tab algn="l" pos="0"/>
+                <a:tab algn="l" pos="3535200"/>
+                <a:tab algn="l" pos="7070760"/>
+                <a:tab algn="l" pos="10605960"/>
+              </a:tabLst>
+            </a:pPr>
+            <a:endParaRPr b="0" lang="en-US" sz="3500" spc="-1" strike="noStrike">
+              <a:solidFill>
+                <a:srgbClr val="000000"/>
+              </a:solidFill>
+              <a:latin typeface="Arial"/>
+            </a:endParaRPr>
+          </a:p>
+          <a:p>
+            <a:pPr algn="just">
+              <a:lnSpc>
+                <a:spcPct val="130000"/>
+              </a:lnSpc>
+              <a:tabLst>
+                <a:tab algn="l" pos="0"/>
+                <a:tab algn="l" pos="3535200"/>
+                <a:tab algn="l" pos="7070760"/>
+                <a:tab algn="l" pos="10605960"/>
+              </a:tabLst>
+            </a:pPr>
+            <a:endParaRPr b="0" lang="en-US" sz="3500" spc="-1" strike="noStrike">
+              <a:solidFill>
+                <a:srgbClr val="000000"/>
+              </a:solidFill>
+              <a:latin typeface="Arial"/>
+            </a:endParaRPr>
+          </a:p>
+          <a:p>
+            <a:pPr algn="just">
+              <a:lnSpc>
+                <a:spcPct val="130000"/>
+              </a:lnSpc>
+              <a:tabLst>
+                <a:tab algn="l" pos="0"/>
+                <a:tab algn="l" pos="3535200"/>
+                <a:tab algn="l" pos="7070760"/>
+                <a:tab algn="l" pos="10605960"/>
+              </a:tabLst>
+            </a:pPr>
+            <a:endParaRPr b="0" lang="en-US" sz="3500" spc="-1" strike="noStrike">
+              <a:solidFill>
+                <a:srgbClr val="000000"/>
+              </a:solidFill>
+              <a:latin typeface="Arial"/>
+            </a:endParaRPr>
+          </a:p>
+          <a:p>
+            <a:pPr algn="just">
+              <a:lnSpc>
+                <a:spcPct val="130000"/>
+              </a:lnSpc>
+              <a:tabLst>
+                <a:tab algn="l" pos="0"/>
+                <a:tab algn="l" pos="3535200"/>
+                <a:tab algn="l" pos="7070760"/>
+                <a:tab algn="l" pos="10605960"/>
+              </a:tabLst>
+            </a:pPr>
+            <a:endParaRPr b="0" lang="en-US" sz="3500" spc="-1" strike="noStrike">
+              <a:solidFill>
+                <a:srgbClr val="000000"/>
+              </a:solidFill>
+              <a:latin typeface="Arial"/>
+            </a:endParaRPr>
+          </a:p>
+          <a:p>
+            <a:pPr algn="just">
+              <a:lnSpc>
+                <a:spcPct val="130000"/>
+              </a:lnSpc>
+              <a:tabLst>
+                <a:tab algn="l" pos="0"/>
+                <a:tab algn="l" pos="3535200"/>
+                <a:tab algn="l" pos="7070760"/>
+                <a:tab algn="l" pos="10605960"/>
+              </a:tabLst>
+            </a:pPr>
+            <a:endParaRPr b="0" lang="en-US" sz="3500" spc="-1" strike="noStrike">
+              <a:solidFill>
+                <a:srgbClr val="000000"/>
+              </a:solidFill>
+              <a:latin typeface="Arial"/>
+            </a:endParaRPr>
+          </a:p>
+          <a:p>
+            <a:pPr algn="just">
+              <a:lnSpc>
+                <a:spcPct val="130000"/>
+              </a:lnSpc>
+              <a:tabLst>
+                <a:tab algn="l" pos="0"/>
+                <a:tab algn="l" pos="3535200"/>
+                <a:tab algn="l" pos="7070760"/>
+                <a:tab algn="l" pos="10605960"/>
+              </a:tabLst>
+            </a:pPr>
+            <a:endParaRPr b="0" lang="en-US" sz="3500" spc="-1" strike="noStrike">
+              <a:solidFill>
+                <a:srgbClr val="000000"/>
+              </a:solidFill>
+              <a:latin typeface="Arial"/>
+            </a:endParaRPr>
+          </a:p>
+          <a:p>
+            <a:pPr algn="just">
+              <a:lnSpc>
+                <a:spcPct val="130000"/>
+              </a:lnSpc>
+              <a:tabLst>
+                <a:tab algn="l" pos="0"/>
+                <a:tab algn="l" pos="3535200"/>
+                <a:tab algn="l" pos="7070760"/>
+                <a:tab algn="l" pos="10605960"/>
+              </a:tabLst>
+            </a:pPr>
+            <a:endParaRPr b="0" lang="en-US" sz="3500" spc="-1" strike="noStrike">
+              <a:solidFill>
+                <a:srgbClr val="000000"/>
+              </a:solidFill>
+              <a:latin typeface="Arial"/>
+            </a:endParaRPr>
+          </a:p>
+          <a:p>
+            <a:pPr algn="just">
+              <a:lnSpc>
+                <a:spcPct val="130000"/>
+              </a:lnSpc>
+              <a:tabLst>
+                <a:tab algn="l" pos="0"/>
+                <a:tab algn="l" pos="3535200"/>
+                <a:tab algn="l" pos="7070760"/>
+                <a:tab algn="l" pos="10605960"/>
+              </a:tabLst>
+            </a:pPr>
+            <a:endParaRPr b="0" lang="en-US" sz="3500" spc="-1" strike="noStrike">
+              <a:solidFill>
+                <a:srgbClr val="000000"/>
+              </a:solidFill>
+              <a:latin typeface="Arial"/>
+            </a:endParaRPr>
+          </a:p>
+          <a:p>
+            <a:pPr algn="just">
+              <a:lnSpc>
+                <a:spcPct val="130000"/>
+              </a:lnSpc>
+              <a:tabLst>
+                <a:tab algn="l" pos="0"/>
+                <a:tab algn="l" pos="3535200"/>
+                <a:tab algn="l" pos="7070760"/>
+                <a:tab algn="l" pos="10605960"/>
+              </a:tabLst>
+            </a:pPr>
+            <a:endParaRPr b="0" lang="en-US" sz="3500" spc="-1" strike="noStrike">
+              <a:solidFill>
+                <a:srgbClr val="000000"/>
+              </a:solidFill>
+              <a:latin typeface="Arial"/>
+            </a:endParaRPr>
+          </a:p>
+          <a:p>
+            <a:pPr algn="just">
+              <a:lnSpc>
+                <a:spcPct val="130000"/>
+              </a:lnSpc>
+              <a:tabLst>
+                <a:tab algn="l" pos="0"/>
+                <a:tab algn="l" pos="3535200"/>
+                <a:tab algn="l" pos="7070760"/>
+                <a:tab algn="l" pos="10605960"/>
+              </a:tabLst>
+            </a:pPr>
+            <a:endParaRPr b="0" lang="en-US" sz="3500" spc="-1" strike="noStrike">
+              <a:solidFill>
+                <a:srgbClr val="000000"/>
+              </a:solidFill>
+              <a:latin typeface="Arial"/>
+            </a:endParaRPr>
+          </a:p>
+          <a:p>
+            <a:pPr algn="just">
+              <a:lnSpc>
+                <a:spcPct val="130000"/>
+              </a:lnSpc>
+              <a:tabLst>
+                <a:tab algn="l" pos="0"/>
+                <a:tab algn="l" pos="3535200"/>
+                <a:tab algn="l" pos="7070760"/>
+                <a:tab algn="l" pos="10605960"/>
+              </a:tabLst>
+            </a:pPr>
+            <a:endParaRPr b="0" lang="en-US" sz="3500" spc="-1" strike="noStrike">
+              <a:solidFill>
+                <a:srgbClr val="000000"/>
+              </a:solidFill>
+              <a:latin typeface="Arial"/>
+            </a:endParaRPr>
+          </a:p>
+          <a:p>
+            <a:pPr algn="just">
+              <a:lnSpc>
+                <a:spcPct val="130000"/>
+              </a:lnSpc>
+              <a:tabLst>
+                <a:tab algn="l" pos="0"/>
+                <a:tab algn="l" pos="3535200"/>
+                <a:tab algn="l" pos="7070760"/>
+                <a:tab algn="l" pos="10605960"/>
+              </a:tabLst>
+            </a:pPr>
+            <a:endParaRPr b="0" lang="en-US" sz="3500" spc="-1" strike="noStrike">
+              <a:solidFill>
+                <a:srgbClr val="000000"/>
+              </a:solidFill>
+              <a:latin typeface="Arial"/>
+            </a:endParaRPr>
+          </a:p>
+          <a:p>
+            <a:pPr algn="just">
+              <a:lnSpc>
+                <a:spcPct val="130000"/>
+              </a:lnSpc>
               <a:tabLst>
                 <a:tab algn="l" pos="0"/>
                 <a:tab algn="l" pos="3535200"/>
@@ -2233,7 +2275,7 @@
           <a:p>
             <a:pPr algn="just" indent="900000">
               <a:lnSpc>
-                <a:spcPct val="150000"/>
+                <a:spcPct val="130000"/>
               </a:lnSpc>
               <a:tabLst>
                 <a:tab algn="l" pos="0"/>
@@ -2250,57 +2292,77 @@
                 <a:latin typeface="Times New Roman"/>
                 <a:ea typeface="Calibri"/>
               </a:rPr>
-              <a:t>Conclui-se que a criança concebida por reprodução assistida póstuma pode figurar como herdeira do genitor falecido, desde que atendida a exigência formal de consentimento expresso, por testamento ou documento análogo, consoante entendimento consolidado tanto pela jurisprudência do STJ quanto pelo anteprojeto de atualização do Código Civil. Trata-se de solução de compromisso que concilia a igualdade entre os filhos, consagrada constitucionalmente, com a segurança jurídica dos demais herdeiros.</a:t>
-            </a:r>
-            <a:endParaRPr b="0" lang="en-US" sz="3500" spc="-1" strike="noStrike">
-              <a:solidFill>
-                <a:srgbClr val="000000"/>
-              </a:solidFill>
-              <a:latin typeface="Arial"/>
-            </a:endParaRPr>
-          </a:p>
-          <a:p>
-            <a:pPr algn="just">
-              <a:lnSpc>
-                <a:spcPct val="150000"/>
-              </a:lnSpc>
-              <a:tabLst>
-                <a:tab algn="l" pos="0"/>
-                <a:tab algn="l" pos="3535200"/>
-                <a:tab algn="l" pos="7070760"/>
-                <a:tab algn="l" pos="10605960"/>
-              </a:tabLst>
-            </a:pPr>
-            <a:endParaRPr b="0" lang="en-US" sz="3500" spc="-1" strike="noStrike">
-              <a:solidFill>
-                <a:srgbClr val="000000"/>
-              </a:solidFill>
-              <a:latin typeface="Arial"/>
-            </a:endParaRPr>
-          </a:p>
-          <a:p>
-            <a:pPr algn="just">
-              <a:lnSpc>
-                <a:spcPct val="150000"/>
-              </a:lnSpc>
-              <a:tabLst>
-                <a:tab algn="l" pos="0"/>
-                <a:tab algn="l" pos="3535200"/>
-                <a:tab algn="l" pos="7070760"/>
-                <a:tab algn="l" pos="10605960"/>
-              </a:tabLst>
-            </a:pPr>
-            <a:endParaRPr b="0" lang="en-US" sz="3500" spc="-1" strike="noStrike">
-              <a:solidFill>
-                <a:srgbClr val="000000"/>
-              </a:solidFill>
-              <a:latin typeface="Arial"/>
-            </a:endParaRPr>
-          </a:p>
-          <a:p>
-            <a:pPr algn="just">
-              <a:lnSpc>
-                <a:spcPct val="150000"/>
+              <a:t>Conclui-se que o </a:t>
+            </a:r>
+            <a:r>
+              <a:rPr b="0" lang="pt-BR" sz="3500" spc="-1" strike="noStrike" i="1">
+                <a:solidFill>
+                  <a:srgbClr val="000000"/>
+                </a:solidFill>
+                <a:latin typeface="Times New Roman"/>
+                <a:ea typeface="Calibri"/>
+              </a:rPr>
+              <a:t>status</a:t>
+            </a:r>
+            <a:r>
+              <a:rPr b="0" lang="pt-BR" sz="3500" spc="-1" strike="noStrike" i="0">
+                <a:solidFill>
+                  <a:srgbClr val="000000"/>
+                </a:solidFill>
+                <a:latin typeface="Times New Roman"/>
+                <a:ea typeface="Calibri"/>
+              </a:rPr>
+              <a:t> jurídico do embrião criopreservado permanece indefinido no ordenamento brasileiro, diante da divergência entre as teorias natalista, concepcionista e da personalidade condicional. Ainda assim, a criança concebida por reprodução assistida póstuma pode figurar como herdeira do genitor falecido, desde que atendida a exigência formal de consentimento expresso, por testamento ou documento análogo, entendimento adotado pelo STJ e que tende a ser consolidado pelo anteprojeto de atualização do Código Civil. Trata-se de solução de compromisso que concilia a igualdade entre os filhos, consagrada constitucionalmente, com a segurança jurídica dos demais herdeiros.</a:t>
+            </a:r>
+            <a:endParaRPr b="0" lang="en-US" sz="3500" spc="-1" strike="noStrike">
+              <a:solidFill>
+                <a:srgbClr val="000000"/>
+              </a:solidFill>
+              <a:latin typeface="Arial"/>
+            </a:endParaRPr>
+          </a:p>
+          <a:p>
+            <a:pPr algn="just">
+              <a:lnSpc>
+                <a:spcPct val="130000"/>
+              </a:lnSpc>
+              <a:tabLst>
+                <a:tab algn="l" pos="0"/>
+                <a:tab algn="l" pos="3535200"/>
+                <a:tab algn="l" pos="7070760"/>
+                <a:tab algn="l" pos="10605960"/>
+              </a:tabLst>
+            </a:pPr>
+            <a:endParaRPr b="0" lang="en-US" sz="3500" spc="-1" strike="noStrike">
+              <a:solidFill>
+                <a:srgbClr val="000000"/>
+              </a:solidFill>
+              <a:latin typeface="Arial"/>
+            </a:endParaRPr>
+          </a:p>
+          <a:p>
+            <a:pPr algn="just">
+              <a:lnSpc>
+                <a:spcPct val="130000"/>
+              </a:lnSpc>
+              <a:tabLst>
+                <a:tab algn="l" pos="0"/>
+                <a:tab algn="l" pos="3535200"/>
+                <a:tab algn="l" pos="7070760"/>
+                <a:tab algn="l" pos="10605960"/>
+              </a:tabLst>
+            </a:pPr>
+            <a:endParaRPr b="0" lang="en-US" sz="3500" spc="-1" strike="noStrike">
+              <a:solidFill>
+                <a:srgbClr val="000000"/>
+              </a:solidFill>
+              <a:latin typeface="Arial"/>
+            </a:endParaRPr>
+          </a:p>
+          <a:p>
+            <a:pPr algn="just">
+              <a:lnSpc>
+                <a:spcPct val="130000"/>
               </a:lnSpc>
               <a:tabLst>
                 <a:tab algn="l" pos="0"/>
@@ -2326,7 +2388,7 @@
         </p:nvSpPr>
         <p:spPr>
           <a:xfrm>
-            <a:off x="16595640" y="16305120"/>
+            <a:off x="16595640" y="16956000"/>
             <a:ext cx="3704040" cy="627480"/>
           </a:xfrm>
           <a:prstGeom prst="rect">
@@ -2386,7 +2448,7 @@
         </p:nvSpPr>
         <p:spPr>
           <a:xfrm>
-            <a:off x="16589520" y="17208360"/>
+            <a:off x="16589520" y="17856000"/>
             <a:ext cx="15104880" cy="15566040"/>
           </a:xfrm>
           <a:prstGeom prst="rect">
@@ -2420,7 +2482,7 @@
               </a:tabLst>
             </a:pPr>
             <a:r>
-              <a:rPr b="0" lang="pt-BR" sz="3000" spc="-1" strike="noStrike">
+              <a:rPr b="0" lang="pt-BR" sz="2800" spc="-1" strike="noStrike">
                 <a:solidFill>
                   <a:srgbClr val="000000"/>
                 </a:solidFill>
@@ -2430,7 +2492,7 @@
               <a:t>ARAUJO, Julia Picinato Medeiros de; ARAUJO, Carlos Henrique Medeiros de. Biodireito e legislação na reprodução assistida. </a:t>
             </a:r>
             <a:r>
-              <a:rPr b="1" lang="pt-BR" sz="3000" spc="-1" strike="noStrike" i="0">
+              <a:rPr b="1" lang="pt-BR" sz="2800" spc="-1" strike="noStrike" i="0">
                 <a:solidFill>
                   <a:srgbClr val="000000"/>
                 </a:solidFill>
@@ -2440,7 +2502,7 @@
               <a:t>Medicina (Ribeirão Preto, Online), v. 51, n. 3, p. 217-235, 2018</a:t>
             </a:r>
             <a:r>
-              <a:rPr b="0" lang="pt-BR" sz="3000" spc="-1" strike="noStrike" i="0">
+              <a:rPr b="0" lang="pt-BR" sz="2800" spc="-1" strike="noStrike" i="0">
                 <a:solidFill>
                   <a:srgbClr val="000000"/>
                 </a:solidFill>
@@ -2468,7 +2530,7 @@
                 <a:tab algn="l" pos="10605960"/>
               </a:tabLst>
             </a:pPr>
-            <a:endParaRPr b="0" lang="en-US" sz="3500" spc="-1" strike="noStrike">
+            <a:endParaRPr b="0" lang="en-US" sz="1400" spc="-1" strike="noStrike">
               <a:solidFill>
                 <a:srgbClr val="000000"/>
               </a:solidFill>
@@ -2488,7 +2550,55 @@
               </a:tabLst>
             </a:pPr>
             <a:r>
-              <a:rPr b="0" lang="pt-BR" sz="3000" spc="-1" strike="noStrike">
+              <a:rPr b="0" lang="pt-BR" sz="2800" spc="-1" strike="noStrike">
+                <a:solidFill>
+                  <a:srgbClr val="000000"/>
+                </a:solidFill>
+                <a:latin typeface="Times New Roman"/>
+                <a:ea typeface="Times New Roman"/>
+              </a:rPr>
+              <a:t>BRASIL. Conselho da Justiça Federal. Enunciado 267. III Jornada de Direito Civil. Comissão de Trabalho: Direito das Sucessões. Brasília, DF: Conselho da Justiça Federal, 2004. Disponível em: https://www.cjf.jus.br/enunciados/enunciado/526. Acesso em: 17 setembro 2026.</a:t>
+            </a:r>
+            <a:endParaRPr b="0" lang="en-US" sz="3500" spc="-1" strike="noStrike">
+              <a:solidFill>
+                <a:srgbClr val="000000"/>
+              </a:solidFill>
+              <a:latin typeface="Arial"/>
+            </a:endParaRPr>
+          </a:p>
+          <a:p>
+            <a:pPr algn="just">
+              <a:lnSpc>
+                <a:spcPct val="100000"/>
+              </a:lnSpc>
+              <a:tabLst>
+                <a:tab algn="l" pos="0"/>
+                <a:tab algn="l" pos="4059360"/>
+                <a:tab algn="l" pos="7070760"/>
+                <a:tab algn="l" pos="10605960"/>
+              </a:tabLst>
+            </a:pPr>
+            <a:endParaRPr b="0" lang="en-US" sz="1400" spc="-1" strike="noStrike">
+              <a:solidFill>
+                <a:srgbClr val="000000"/>
+              </a:solidFill>
+              <a:latin typeface="Arial"/>
+            </a:endParaRPr>
+          </a:p>
+          <a:p>
+            <a:pPr algn="just">
+              <a:lnSpc>
+                <a:spcPct val="100000"/>
+              </a:lnSpc>
+              <a:tabLst>
+                <a:tab algn="l" pos="0"/>
+                <a:tab algn="l" pos="4059360"/>
+                <a:tab algn="l" pos="7070760"/>
+                <a:tab algn="l" pos="10605960"/>
+              </a:tabLst>
+            </a:pPr>
+            <a:r>
+              <a:rPr b="0" lang="pt-BR" sz="2800" spc="-1" strike="noStrike">
                 <a:solidFill>
                   <a:srgbClr val="000000"/>
                 </a:solidFill>
@@ -2516,7 +2626,7 @@
                 <a:tab algn="l" pos="10605960"/>
               </a:tabLst>
             </a:pPr>
-            <a:endParaRPr b="0" lang="en-US" sz="3500" spc="-1" strike="noStrike">
+            <a:endParaRPr b="0" lang="en-US" sz="1400" spc="-1" strike="noStrike">
               <a:solidFill>
                 <a:srgbClr val="000000"/>
               </a:solidFill>
@@ -2536,7 +2646,7 @@
               </a:tabLst>
             </a:pPr>
             <a:r>
-              <a:rPr b="0" lang="pt-BR" sz="3000" spc="-1" strike="noStrike">
+              <a:rPr b="0" lang="pt-BR" sz="2800" spc="-1" strike="noStrike">
                 <a:solidFill>
                   <a:srgbClr val="000000"/>
                 </a:solidFill>
@@ -2564,7 +2674,7 @@
                 <a:tab algn="l" pos="10605960"/>
               </a:tabLst>
             </a:pPr>
-            <a:endParaRPr b="0" lang="en-US" sz="3500" spc="-1" strike="noStrike">
+            <a:endParaRPr b="0" lang="en-US" sz="1400" spc="-1" strike="noStrike">
               <a:solidFill>
                 <a:srgbClr val="000000"/>
               </a:solidFill>
@@ -2584,7 +2694,7 @@
               </a:tabLst>
             </a:pPr>
             <a:r>
-              <a:rPr b="0" lang="pt-BR" sz="3000" spc="-1" strike="noStrike">
+              <a:rPr b="0" lang="pt-BR" sz="2800" spc="-1" strike="noStrike">
                 <a:solidFill>
                   <a:srgbClr val="000000"/>
                 </a:solidFill>
@@ -2612,7 +2722,7 @@
                 <a:tab algn="l" pos="10605960"/>
               </a:tabLst>
             </a:pPr>
-            <a:endParaRPr b="0" lang="en-US" sz="3500" spc="-1" strike="noStrike">
+            <a:endParaRPr b="0" lang="en-US" sz="1400" spc="-1" strike="noStrike">
               <a:solidFill>
                 <a:srgbClr val="000000"/>
               </a:solidFill>
@@ -2632,7 +2742,7 @@
               </a:tabLst>
             </a:pPr>
             <a:r>
-              <a:rPr b="0" lang="pt-BR" sz="3000" spc="-1" strike="noStrike">
+              <a:rPr b="0" lang="pt-BR" sz="2800" spc="-1" strike="noStrike">
                 <a:solidFill>
                   <a:srgbClr val="000000"/>
                 </a:solidFill>
@@ -2660,7 +2770,7 @@
                 <a:tab algn="l" pos="10605960"/>
               </a:tabLst>
             </a:pPr>
-            <a:endParaRPr b="0" lang="en-US" sz="3500" spc="-1" strike="noStrike">
+            <a:endParaRPr b="0" lang="en-US" sz="1400" spc="-1" strike="noStrike">
               <a:solidFill>
                 <a:srgbClr val="000000"/>
               </a:solidFill>
@@ -2680,7 +2790,7 @@
               </a:tabLst>
             </a:pPr>
             <a:r>
-              <a:rPr b="0" lang="pt-BR" sz="3000" spc="-1" strike="noStrike">
+              <a:rPr b="0" lang="pt-BR" sz="2800" spc="-1" strike="noStrike">
                 <a:solidFill>
                   <a:srgbClr val="000000"/>
                 </a:solidFill>
@@ -2690,7 +2800,7 @@
               <a:t>BRASIL. Superior Tribunal de Justiça. Recurso Especial n. 1.918.421/SP. Relator: Ministro Marco Buzzi. Relator para acórdão: Ministro Luis Felipe Salomão. Data de julgamento: 8 jun. 2021. Disponível em:</a:t>
             </a:r>
             <a:r>
-              <a:rPr b="0" lang="pt-BR" sz="3000" spc="-1" strike="noStrike">
+              <a:rPr b="0" lang="pt-BR" sz="2800" spc="-1" strike="noStrike">
                 <a:solidFill>
                   <a:srgbClr val="000000"/>
                 </a:solidFill>
@@ -2718,7 +2828,7 @@
                 <a:tab algn="l" pos="10605960"/>
               </a:tabLst>
             </a:pPr>
-            <a:endParaRPr b="0" lang="en-US" sz="3500" spc="-1" strike="noStrike">
+            <a:endParaRPr b="0" lang="en-US" sz="1400" spc="-1" strike="noStrike">
               <a:solidFill>
                 <a:srgbClr val="000000"/>
               </a:solidFill>
@@ -2738,7 +2848,7 @@
               </a:tabLst>
             </a:pPr>
             <a:r>
-              <a:rPr b="0" lang="pt-BR" sz="3000" spc="-1" strike="noStrike">
+              <a:rPr b="0" lang="pt-BR" sz="2800" spc="-1" strike="noStrike">
                 <a:solidFill>
                   <a:srgbClr val="000000"/>
                 </a:solidFill>
@@ -2748,7 +2858,7 @@
               <a:t>GONÇALVES, Carlos Roberto. </a:t>
             </a:r>
             <a:r>
-              <a:rPr b="1" lang="pt-BR" sz="3000" spc="-1" strike="noStrike">
+              <a:rPr b="1" lang="pt-BR" sz="2800" spc="-1" strike="noStrike">
                 <a:solidFill>
                   <a:srgbClr val="000000"/>
                 </a:solidFill>
@@ -2758,7 +2868,7 @@
               <a:t>Direito Civil Brasileiro - Direito das Sucessões Vol. 7 - 20ª Edição 2026</a:t>
             </a:r>
             <a:r>
-              <a:rPr b="0" lang="pt-BR" sz="3000" spc="-1" strike="noStrike">
+              <a:rPr b="0" lang="pt-BR" sz="2800" spc="-1" strike="noStrike">
                 <a:solidFill>
                   <a:srgbClr val="000000"/>
                 </a:solidFill>
@@ -2768,7 +2878,7 @@
               <a:t>. 20. ed. Rio de Janeiro: SRV, 2026. </a:t>
             </a:r>
             <a:r>
-              <a:rPr b="0" i="1" lang="pt-BR" sz="3000" spc="-1" strike="noStrike">
+              <a:rPr b="0" i="1" lang="pt-BR" sz="2800" spc="-1" strike="noStrike">
                 <a:solidFill>
                   <a:srgbClr val="000000"/>
                 </a:solidFill>
@@ -2778,7 +2888,7 @@
               <a:t>E-book.</a:t>
             </a:r>
             <a:r>
-              <a:rPr b="0" lang="pt-BR" sz="3000" spc="-1" strike="noStrike">
+              <a:rPr b="0" lang="pt-BR" sz="2800" spc="-1" strike="noStrike">
                 <a:solidFill>
                   <a:srgbClr val="000000"/>
                 </a:solidFill>
@@ -2806,7 +2916,7 @@
                 <a:tab algn="l" pos="10605960"/>
               </a:tabLst>
             </a:pPr>
-            <a:endParaRPr b="0" lang="en-US" sz="3500" spc="-1" strike="noStrike">
+            <a:endParaRPr b="0" lang="en-US" sz="1400" spc="-1" strike="noStrike">
               <a:solidFill>
                 <a:srgbClr val="000000"/>
               </a:solidFill>
@@ -2826,7 +2936,7 @@
               </a:tabLst>
             </a:pPr>
             <a:r>
-              <a:rPr b="0" lang="pt-BR" sz="3000" spc="-1" strike="noStrike">
+              <a:rPr b="0" lang="pt-BR" sz="2800" spc="-1" strike="noStrike">
                 <a:solidFill>
                   <a:srgbClr val="000000"/>
                 </a:solidFill>
@@ -2836,7 +2946,7 @@
               <a:t>MARTINS, Brenda Woloski; WINCK, Morgana Dulce; MIRANDA, Roberta Drehmer de. Reprodução assistida </a:t>
             </a:r>
             <a:r>
-              <a:rPr b="0" i="1" lang="pt-BR" sz="3000" spc="-1" strike="noStrike">
+              <a:rPr b="0" i="1" lang="pt-BR" sz="2800" spc="-1" strike="noStrike">
                 <a:solidFill>
                   <a:srgbClr val="000000"/>
                 </a:solidFill>
@@ -2846,7 +2956,7 @@
               <a:t>post mortem</a:t>
             </a:r>
             <a:r>
-              <a:rPr b="0" lang="pt-BR" sz="3000" spc="-1" strike="noStrike">
+              <a:rPr b="0" lang="pt-BR" sz="2800" spc="-1" strike="noStrike">
                 <a:solidFill>
                   <a:srgbClr val="000000"/>
                 </a:solidFill>
@@ -2856,7 +2966,7 @@
               <a:t> no projeto de Código Civil. </a:t>
             </a:r>
             <a:r>
-              <a:rPr b="1" lang="pt-BR" sz="3000" spc="-1" strike="noStrike">
+              <a:rPr b="1" lang="pt-BR" sz="2800" spc="-1" strike="noStrike">
                 <a:solidFill>
                   <a:srgbClr val="000000"/>
                 </a:solidFill>
@@ -2866,7 +2976,7 @@
               <a:t>Res Severa Verum Gaudium, Porto Alegre, v. 11, n. 1bis, p. 315-321, jul. 2026</a:t>
             </a:r>
             <a:r>
-              <a:rPr b="0" lang="pt-BR" sz="3000" spc="-1" strike="noStrike">
+              <a:rPr b="0" lang="pt-BR" sz="2800" spc="-1" strike="noStrike">
                 <a:solidFill>
                   <a:srgbClr val="000000"/>
                 </a:solidFill>

</xml_diff>

<commit_message>
Banner: fim do Referencial Teórico volta para a 1ª coluna
Co-Authored-By: Claude Opus 5.5 <noreply@anthropic.com>
Claude-Session: https://claude.ai/code/session_0176U9jodFC8XWfeFASD67mk
</commit_message>
<xml_diff>
--- a/Banner_TCC_Ana_Livia_final.pptx
+++ b/Banner_TCC_Ana_Livia_final.pptx
@@ -1429,277 +1429,18 @@
               </a:rPr>
               <a:t>O Anteprojeto de Reforma do Código Civil (2026) tende a consolidar esse entendimento, exigindo escritura pública ou testamento público para a autorização do uso póstumo do material genético e fixando prazo de dois anos, contado da abertura da sucessão, para os efeitos sucessórios patrimoniais</a:t>
             </a:r>
-            <a:endParaRPr b="0" lang="en-US" sz="3500" spc="-1" strike="noStrike">
-              <a:solidFill>
-                <a:srgbClr val="000000"/>
-              </a:solidFill>
-              <a:latin typeface="Arial"/>
-            </a:endParaRPr>
-          </a:p>
-          <a:p>
-            <a:pPr algn="just">
-              <a:lnSpc>
-                <a:spcPct val="130000"/>
-              </a:lnSpc>
-              <a:tabLst>
-                <a:tab algn="l" pos="0"/>
-                <a:tab algn="l" pos="3535200"/>
-                <a:tab algn="l" pos="7070760"/>
-                <a:tab algn="l" pos="10605960"/>
-              </a:tabLst>
-            </a:pPr>
-            <a:endParaRPr b="0" lang="en-US" sz="3500" spc="-1" strike="noStrike">
-              <a:solidFill>
-                <a:srgbClr val="000000"/>
-              </a:solidFill>
-              <a:latin typeface="Arial"/>
-            </a:endParaRPr>
-          </a:p>
-          <a:p>
-            <a:pPr algn="just">
-              <a:lnSpc>
-                <a:spcPct val="130000"/>
-              </a:lnSpc>
-              <a:tabLst>
-                <a:tab algn="l" pos="0"/>
-                <a:tab algn="l" pos="3535200"/>
-                <a:tab algn="l" pos="7070760"/>
-                <a:tab algn="l" pos="10605960"/>
-              </a:tabLst>
-            </a:pPr>
-            <a:endParaRPr b="0" lang="en-US" sz="3500" spc="-1" strike="noStrike">
-              <a:solidFill>
-                <a:srgbClr val="000000"/>
-              </a:solidFill>
-              <a:latin typeface="Arial"/>
-            </a:endParaRPr>
-          </a:p>
-          <a:p>
-            <a:pPr algn="just">
-              <a:lnSpc>
-                <a:spcPct val="130000"/>
-              </a:lnSpc>
-              <a:tabLst>
-                <a:tab algn="l" pos="0"/>
-                <a:tab algn="l" pos="3535200"/>
-                <a:tab algn="l" pos="7070760"/>
-                <a:tab algn="l" pos="10605960"/>
-              </a:tabLst>
-            </a:pPr>
-            <a:endParaRPr b="0" lang="en-US" sz="3500" spc="-1" strike="noStrike">
-              <a:solidFill>
-                <a:srgbClr val="000000"/>
-              </a:solidFill>
-              <a:latin typeface="Arial"/>
-            </a:endParaRPr>
-          </a:p>
-          <a:p>
-            <a:pPr algn="just">
-              <a:lnSpc>
-                <a:spcPct val="130000"/>
-              </a:lnSpc>
-              <a:tabLst>
-                <a:tab algn="l" pos="0"/>
-                <a:tab algn="l" pos="3535200"/>
-                <a:tab algn="l" pos="7070760"/>
-                <a:tab algn="l" pos="10605960"/>
-              </a:tabLst>
-            </a:pPr>
-            <a:endParaRPr b="0" lang="en-US" sz="3500" spc="-1" strike="noStrike">
-              <a:solidFill>
-                <a:srgbClr val="000000"/>
-              </a:solidFill>
-              <a:latin typeface="Arial"/>
-            </a:endParaRPr>
-          </a:p>
-          <a:p>
-            <a:pPr algn="just">
-              <a:lnSpc>
-                <a:spcPct val="130000"/>
-              </a:lnSpc>
-              <a:tabLst>
-                <a:tab algn="l" pos="0"/>
-                <a:tab algn="l" pos="3535200"/>
-                <a:tab algn="l" pos="7070760"/>
-                <a:tab algn="l" pos="10605960"/>
-              </a:tabLst>
-            </a:pPr>
-            <a:endParaRPr b="0" lang="en-US" sz="3500" spc="-1" strike="noStrike">
-              <a:solidFill>
-                <a:srgbClr val="000000"/>
-              </a:solidFill>
-              <a:latin typeface="Arial"/>
-            </a:endParaRPr>
-          </a:p>
-          <a:p>
-            <a:pPr algn="just">
-              <a:lnSpc>
-                <a:spcPct val="130000"/>
-              </a:lnSpc>
-              <a:tabLst>
-                <a:tab algn="l" pos="0"/>
-                <a:tab algn="l" pos="3535200"/>
-                <a:tab algn="l" pos="7070760"/>
-                <a:tab algn="l" pos="10605960"/>
-              </a:tabLst>
-            </a:pPr>
-            <a:endParaRPr b="0" lang="en-US" sz="3500" spc="-1" strike="noStrike">
-              <a:solidFill>
-                <a:srgbClr val="000000"/>
-              </a:solidFill>
-              <a:latin typeface="Arial"/>
-            </a:endParaRPr>
-          </a:p>
-          <a:p>
-            <a:pPr algn="just">
-              <a:lnSpc>
-                <a:spcPct val="130000"/>
-              </a:lnSpc>
-              <a:tabLst>
-                <a:tab algn="l" pos="0"/>
-                <a:tab algn="l" pos="3535200"/>
-                <a:tab algn="l" pos="7070760"/>
-                <a:tab algn="l" pos="10605960"/>
-              </a:tabLst>
-            </a:pPr>
-            <a:endParaRPr b="0" lang="en-US" sz="3500" spc="-1" strike="noStrike">
-              <a:solidFill>
-                <a:srgbClr val="000000"/>
-              </a:solidFill>
-              <a:latin typeface="Arial"/>
-            </a:endParaRPr>
-          </a:p>
-          <a:p>
-            <a:pPr algn="just">
-              <a:lnSpc>
-                <a:spcPct val="130000"/>
-              </a:lnSpc>
-              <a:tabLst>
-                <a:tab algn="l" pos="0"/>
-                <a:tab algn="l" pos="3535200"/>
-                <a:tab algn="l" pos="7070760"/>
-                <a:tab algn="l" pos="10605960"/>
-              </a:tabLst>
-            </a:pPr>
-            <a:endParaRPr b="0" lang="en-US" sz="3500" spc="-1" strike="noStrike">
-              <a:solidFill>
-                <a:srgbClr val="000000"/>
-              </a:solidFill>
-              <a:latin typeface="Arial"/>
-            </a:endParaRPr>
-          </a:p>
-          <a:p>
-            <a:pPr algn="just">
-              <a:lnSpc>
-                <a:spcPct val="130000"/>
-              </a:lnSpc>
-              <a:tabLst>
-                <a:tab algn="l" pos="0"/>
-                <a:tab algn="l" pos="3535200"/>
-                <a:tab algn="l" pos="7070760"/>
-                <a:tab algn="l" pos="10605960"/>
-              </a:tabLst>
-            </a:pPr>
-            <a:endParaRPr b="0" lang="en-US" sz="3500" spc="-1" strike="noStrike">
-              <a:solidFill>
-                <a:srgbClr val="000000"/>
-              </a:solidFill>
-              <a:latin typeface="Arial"/>
-            </a:endParaRPr>
-          </a:p>
-          <a:p>
-            <a:pPr algn="just">
-              <a:lnSpc>
-                <a:spcPct val="130000"/>
-              </a:lnSpc>
-              <a:tabLst>
-                <a:tab algn="l" pos="0"/>
-                <a:tab algn="l" pos="3535200"/>
-                <a:tab algn="l" pos="7070760"/>
-                <a:tab algn="l" pos="10605960"/>
-              </a:tabLst>
-            </a:pPr>
-            <a:endParaRPr b="0" lang="en-US" sz="3500" spc="-1" strike="noStrike">
-              <a:solidFill>
-                <a:srgbClr val="000000"/>
-              </a:solidFill>
-              <a:latin typeface="Arial"/>
-            </a:endParaRPr>
-          </a:p>
-          <a:p>
-            <a:pPr algn="just">
-              <a:lnSpc>
-                <a:spcPct val="130000"/>
-              </a:lnSpc>
-              <a:tabLst>
-                <a:tab algn="l" pos="0"/>
-                <a:tab algn="l" pos="3535200"/>
-                <a:tab algn="l" pos="7070760"/>
-                <a:tab algn="l" pos="10605960"/>
-              </a:tabLst>
-            </a:pPr>
-            <a:endParaRPr b="0" lang="en-US" sz="3500" spc="-1" strike="noStrike">
-              <a:solidFill>
-                <a:srgbClr val="000000"/>
-              </a:solidFill>
-              <a:latin typeface="Arial"/>
-            </a:endParaRPr>
-          </a:p>
-        </p:txBody>
-      </p:sp>
-      <p:sp>
-        <p:nvSpPr>
-          <p:cNvPr id="15" name="Retângulo 8"/>
-          <p:cNvSpPr/>
-          <p:nvPr/>
-        </p:nvSpPr>
-        <p:spPr>
-          <a:xfrm>
-            <a:off x="16570440" y="8634240"/>
-            <a:ext cx="14994000" cy="13698720"/>
-          </a:xfrm>
-          <a:prstGeom prst="rect">
-            <a:avLst/>
-          </a:prstGeom>
-          <a:noFill/>
-          <a:ln w="0">
-            <a:noFill/>
-          </a:ln>
-        </p:spPr>
-        <p:style>
-          <a:lnRef idx="0"/>
-          <a:fillRef idx="0"/>
-          <a:effectRef idx="0"/>
-          <a:fontRef idx="minor"/>
-        </p:style>
-        <p:txBody>
-          <a:bodyPr lIns="90000" rIns="90000" tIns="46800" bIns="46800" anchor="t">
-            <a:spAutoFit/>
-          </a:bodyPr>
-          <a:p>
-            <a:pPr algn="just">
-              <a:lnSpc>
-                <a:spcPct val="130000"/>
-              </a:lnSpc>
-              <a:tabLst>
-                <a:tab algn="l" pos="0"/>
-                <a:tab algn="l" pos="3535200"/>
-                <a:tab algn="l" pos="7070760"/>
-                <a:tab algn="l" pos="10605960"/>
-              </a:tabLst>
-            </a:pPr>
-            <a:r>
-              <a:rPr b="0" lang="pt-BR" sz="3500" spc="-1" strike="noStrike">
+            <a:r>
+              <a:rPr b="0" lang="pt-BR" sz="3500" spc="-1" strike="noStrike" i="0">
                 <a:solidFill>
                   <a:srgbClr val="000000"/>
                 </a:solidFill>
                 <a:latin typeface="Times New Roman"/>
                 <a:ea typeface="Calibri"/>
               </a:rPr>
-              <a:t>em favor do filho concebido </a:t>
-            </a:r>
-            <a:r>
-              <a:rPr b="0" i="1" lang="pt-BR" sz="3500" spc="-1" strike="noStrike">
+              <a:t> em favor do filho concebido </a:t>
+            </a:r>
+            <a:r>
+              <a:rPr b="0" lang="pt-BR" sz="3500" spc="-1" strike="noStrike" i="1">
                 <a:solidFill>
                   <a:srgbClr val="000000"/>
                 </a:solidFill>
@@ -1709,7 +1450,7 @@
               <a:t>post mortem</a:t>
             </a:r>
             <a:r>
-              <a:rPr b="0" lang="pt-BR" sz="3500" spc="-1" strike="noStrike">
+              <a:rPr b="0" lang="pt-BR" sz="3500" spc="-1" strike="noStrike" i="0">
                 <a:solidFill>
                   <a:srgbClr val="000000"/>
                 </a:solidFill>
@@ -1718,253 +1459,6 @@
               </a:rPr>
               <a:t>.</a:t>
             </a:r>
-            <a:endParaRPr b="0" lang="en-US" sz="3500" spc="-1" strike="noStrike">
-              <a:solidFill>
-                <a:srgbClr val="000000"/>
-              </a:solidFill>
-              <a:latin typeface="Arial"/>
-            </a:endParaRPr>
-          </a:p>
-          <a:p>
-            <a:pPr algn="just">
-              <a:lnSpc>
-                <a:spcPct val="130000"/>
-              </a:lnSpc>
-              <a:tabLst>
-                <a:tab algn="l" pos="0"/>
-                <a:tab algn="l" pos="3535200"/>
-                <a:tab algn="l" pos="7070760"/>
-                <a:tab algn="l" pos="10605960"/>
-              </a:tabLst>
-            </a:pPr>
-            <a:endParaRPr b="0" lang="en-US" sz="3500" spc="-1" strike="noStrike">
-              <a:solidFill>
-                <a:srgbClr val="000000"/>
-              </a:solidFill>
-              <a:latin typeface="Arial"/>
-            </a:endParaRPr>
-          </a:p>
-          <a:p>
-            <a:pPr algn="just">
-              <a:lnSpc>
-                <a:spcPct val="130000"/>
-              </a:lnSpc>
-              <a:tabLst>
-                <a:tab algn="l" pos="0"/>
-                <a:tab algn="l" pos="3535200"/>
-                <a:tab algn="l" pos="7070760"/>
-                <a:tab algn="l" pos="10605960"/>
-              </a:tabLst>
-            </a:pPr>
-            <a:endParaRPr b="0" lang="en-US" sz="3500" spc="-1" strike="noStrike">
-              <a:solidFill>
-                <a:srgbClr val="000000"/>
-              </a:solidFill>
-              <a:latin typeface="Arial"/>
-            </a:endParaRPr>
-          </a:p>
-          <a:p>
-            <a:pPr algn="just">
-              <a:lnSpc>
-                <a:spcPct val="130000"/>
-              </a:lnSpc>
-              <a:tabLst>
-                <a:tab algn="l" pos="0"/>
-                <a:tab algn="l" pos="3535200"/>
-                <a:tab algn="l" pos="7070760"/>
-                <a:tab algn="l" pos="10605960"/>
-              </a:tabLst>
-            </a:pPr>
-            <a:endParaRPr b="0" lang="en-US" sz="3500" spc="-1" strike="noStrike">
-              <a:solidFill>
-                <a:srgbClr val="000000"/>
-              </a:solidFill>
-              <a:latin typeface="Arial"/>
-            </a:endParaRPr>
-          </a:p>
-          <a:p>
-            <a:pPr algn="just">
-              <a:lnSpc>
-                <a:spcPct val="130000"/>
-              </a:lnSpc>
-              <a:tabLst>
-                <a:tab algn="l" pos="0"/>
-                <a:tab algn="l" pos="3535200"/>
-                <a:tab algn="l" pos="7070760"/>
-                <a:tab algn="l" pos="10605960"/>
-              </a:tabLst>
-            </a:pPr>
-            <a:endParaRPr b="0" lang="en-US" sz="3500" spc="-1" strike="noStrike">
-              <a:solidFill>
-                <a:srgbClr val="000000"/>
-              </a:solidFill>
-              <a:latin typeface="Arial"/>
-            </a:endParaRPr>
-          </a:p>
-          <a:p>
-            <a:pPr algn="just">
-              <a:lnSpc>
-                <a:spcPct val="130000"/>
-              </a:lnSpc>
-              <a:tabLst>
-                <a:tab algn="l" pos="0"/>
-                <a:tab algn="l" pos="3535200"/>
-                <a:tab algn="l" pos="7070760"/>
-                <a:tab algn="l" pos="10605960"/>
-              </a:tabLst>
-            </a:pPr>
-            <a:endParaRPr b="0" lang="en-US" sz="3500" spc="-1" strike="noStrike">
-              <a:solidFill>
-                <a:srgbClr val="000000"/>
-              </a:solidFill>
-              <a:latin typeface="Arial"/>
-            </a:endParaRPr>
-          </a:p>
-          <a:p>
-            <a:pPr algn="just">
-              <a:lnSpc>
-                <a:spcPct val="130000"/>
-              </a:lnSpc>
-              <a:tabLst>
-                <a:tab algn="l" pos="0"/>
-                <a:tab algn="l" pos="3535200"/>
-                <a:tab algn="l" pos="7070760"/>
-                <a:tab algn="l" pos="10605960"/>
-              </a:tabLst>
-            </a:pPr>
-            <a:endParaRPr b="0" lang="en-US" sz="3500" spc="-1" strike="noStrike">
-              <a:solidFill>
-                <a:srgbClr val="000000"/>
-              </a:solidFill>
-              <a:latin typeface="Arial"/>
-            </a:endParaRPr>
-          </a:p>
-          <a:p>
-            <a:pPr algn="just">
-              <a:lnSpc>
-                <a:spcPct val="130000"/>
-              </a:lnSpc>
-              <a:tabLst>
-                <a:tab algn="l" pos="0"/>
-                <a:tab algn="l" pos="3535200"/>
-                <a:tab algn="l" pos="7070760"/>
-                <a:tab algn="l" pos="10605960"/>
-              </a:tabLst>
-            </a:pPr>
-            <a:endParaRPr b="0" lang="en-US" sz="3500" spc="-1" strike="noStrike">
-              <a:solidFill>
-                <a:srgbClr val="000000"/>
-              </a:solidFill>
-              <a:latin typeface="Arial"/>
-            </a:endParaRPr>
-          </a:p>
-          <a:p>
-            <a:pPr algn="just">
-              <a:lnSpc>
-                <a:spcPct val="130000"/>
-              </a:lnSpc>
-              <a:tabLst>
-                <a:tab algn="l" pos="0"/>
-                <a:tab algn="l" pos="3535200"/>
-                <a:tab algn="l" pos="7070760"/>
-                <a:tab algn="l" pos="10605960"/>
-              </a:tabLst>
-            </a:pPr>
-            <a:endParaRPr b="0" lang="en-US" sz="3500" spc="-1" strike="noStrike">
-              <a:solidFill>
-                <a:srgbClr val="000000"/>
-              </a:solidFill>
-              <a:latin typeface="Arial"/>
-            </a:endParaRPr>
-          </a:p>
-          <a:p>
-            <a:pPr algn="just">
-              <a:lnSpc>
-                <a:spcPct val="130000"/>
-              </a:lnSpc>
-              <a:tabLst>
-                <a:tab algn="l" pos="0"/>
-                <a:tab algn="l" pos="3535200"/>
-                <a:tab algn="l" pos="7070760"/>
-                <a:tab algn="l" pos="10605960"/>
-              </a:tabLst>
-            </a:pPr>
-            <a:endParaRPr b="0" lang="en-US" sz="3500" spc="-1" strike="noStrike">
-              <a:solidFill>
-                <a:srgbClr val="000000"/>
-              </a:solidFill>
-              <a:latin typeface="Arial"/>
-            </a:endParaRPr>
-          </a:p>
-          <a:p>
-            <a:pPr algn="just">
-              <a:lnSpc>
-                <a:spcPct val="130000"/>
-              </a:lnSpc>
-              <a:tabLst>
-                <a:tab algn="l" pos="0"/>
-                <a:tab algn="l" pos="3535200"/>
-                <a:tab algn="l" pos="7070760"/>
-                <a:tab algn="l" pos="10605960"/>
-              </a:tabLst>
-            </a:pPr>
-            <a:endParaRPr b="0" lang="en-US" sz="3500" spc="-1" strike="noStrike">
-              <a:solidFill>
-                <a:srgbClr val="000000"/>
-              </a:solidFill>
-              <a:latin typeface="Arial"/>
-            </a:endParaRPr>
-          </a:p>
-          <a:p>
-            <a:pPr algn="just">
-              <a:lnSpc>
-                <a:spcPct val="130000"/>
-              </a:lnSpc>
-              <a:tabLst>
-                <a:tab algn="l" pos="0"/>
-                <a:tab algn="l" pos="3535200"/>
-                <a:tab algn="l" pos="7070760"/>
-                <a:tab algn="l" pos="10605960"/>
-              </a:tabLst>
-            </a:pPr>
-            <a:endParaRPr b="0" lang="en-US" sz="3500" spc="-1" strike="noStrike">
-              <a:solidFill>
-                <a:srgbClr val="000000"/>
-              </a:solidFill>
-              <a:latin typeface="Arial"/>
-            </a:endParaRPr>
-          </a:p>
-          <a:p>
-            <a:pPr algn="just">
-              <a:lnSpc>
-                <a:spcPct val="130000"/>
-              </a:lnSpc>
-              <a:tabLst>
-                <a:tab algn="l" pos="0"/>
-                <a:tab algn="l" pos="3535200"/>
-                <a:tab algn="l" pos="7070760"/>
-                <a:tab algn="l" pos="10605960"/>
-              </a:tabLst>
-            </a:pPr>
-            <a:endParaRPr b="0" lang="en-US" sz="3500" spc="-1" strike="noStrike">
-              <a:solidFill>
-                <a:srgbClr val="000000"/>
-              </a:solidFill>
-              <a:latin typeface="Arial"/>
-            </a:endParaRPr>
-          </a:p>
-          <a:p>
-            <a:pPr algn="just">
-              <a:lnSpc>
-                <a:spcPct val="130000"/>
-              </a:lnSpc>
-              <a:tabLst>
-                <a:tab algn="l" pos="0"/>
-                <a:tab algn="l" pos="3535200"/>
-                <a:tab algn="l" pos="7070760"/>
-                <a:tab algn="l" pos="10605960"/>
-              </a:tabLst>
-            </a:pPr>
             <a:endParaRPr b="0" lang="en-US" sz="3500" spc="-1" strike="noStrike">
               <a:solidFill>
                 <a:srgbClr val="000000"/>
@@ -2191,7 +1685,7 @@
         </p:nvSpPr>
         <p:spPr>
           <a:xfrm>
-            <a:off x="16597440" y="9674280"/>
+            <a:off x="16597440" y="8696160"/>
             <a:ext cx="6127200" cy="627480"/>
           </a:xfrm>
           <a:prstGeom prst="rect">
@@ -2251,7 +1745,7 @@
         </p:nvSpPr>
         <p:spPr>
           <a:xfrm>
-            <a:off x="16578360" y="10304640"/>
+            <a:off x="16578360" y="9326520"/>
             <a:ext cx="14994000" cy="8096760"/>
           </a:xfrm>
           <a:prstGeom prst="rect">
@@ -2388,7 +1882,7 @@
         </p:nvSpPr>
         <p:spPr>
           <a:xfrm>
-            <a:off x="16595640" y="16956000"/>
+            <a:off x="16595640" y="15977880"/>
             <a:ext cx="3704040" cy="627480"/>
           </a:xfrm>
           <a:prstGeom prst="rect">
@@ -2448,7 +1942,7 @@
         </p:nvSpPr>
         <p:spPr>
           <a:xfrm>
-            <a:off x="16589520" y="17856000"/>
+            <a:off x="16589520" y="16877880"/>
             <a:ext cx="15104880" cy="15566040"/>
           </a:xfrm>
           <a:prstGeom prst="rect">

</xml_diff>